<commit_message>
Ruth Soriano: cifras de pruebas, actores y tabla de servicios
- Reporte: actores sin el servicio de notificaciones (entregas, seguimiento y documentos
  para el repartidor; bandeja del portal para los avisos) y cifras de pruebas de Android
  (46 + 3) y escritorio (64) al dia.
- Presentacion: la diapositiva 8 lista un servicio por fila (10 filas) y la 27 indica
  cada servicio con su puerto.
- Documentacion de la app de escritorio con 35 + 29 = 64 comprobaciones.
</commit_message>
<xml_diff>
--- a/presentacion/Microhubs_Presentacion.pptx
+++ b/presentacion/Microhubs_Presentacion.pptx
@@ -22823,7 +22823,7 @@
                           <a:ea typeface="Comfortaa"/>
                           <a:cs typeface="Comfortaa"/>
                         </a:rPr>
-                        <a:t>Documentos / Planeación</a:t>
+                        <a:t>Documentos :5107 y Planeación :5106</a:t>
                       </a:r>
                     </a:p>
                   </a:txBody>
@@ -23055,7 +23055,7 @@
                           <a:ea typeface="Comfortaa"/>
                           <a:cs typeface="Comfortaa"/>
                         </a:rPr>
-                        <a:t>Pedidos / Entregas</a:t>
+                        <a:t>Pedidos :5104 y Entregas :5105</a:t>
                       </a:r>
                     </a:p>
                   </a:txBody>
@@ -31360,7 +31360,7 @@
         </p:nvGraphicFramePr>
         <p:xfrm>
           <a:off xmlns:a="http://schemas.openxmlformats.org/drawingml/2006/main" x="619125" y="1543050"/>
-          <a:ext xmlns:a="http://schemas.openxmlformats.org/drawingml/2006/main" cx="10953750" cy="4434840"/>
+          <a:ext xmlns:a="http://schemas.openxmlformats.org/drawingml/2006/main" cx="10953750" cy="4576572"/>
         </p:xfrm>
         <a:graphic xmlns:a="http://schemas.openxmlformats.org/drawingml/2006/main">
           <a:graphicData uri="http://schemas.openxmlformats.org/drawingml/2006/table">
@@ -31371,7 +31371,7 @@
                 <a:gridCol w="2095500"/>
                 <a:gridCol w="6000750"/>
               </a:tblGrid>
-              <a:tr h="554355">
+              <a:tr h="416052">
                 <a:tc>
                   <a:txBody>
                     <a:bodyPr/>
@@ -31505,7 +31505,7 @@
                   </a:tcPr>
                 </a:tc>
               </a:tr>
-              <a:tr h="554355">
+              <a:tr h="416052">
                 <a:tc>
                   <a:txBody>
                     <a:bodyPr/>
@@ -31520,7 +31520,7 @@
                           <a:ea typeface="Comfortaa"/>
                           <a:cs typeface="Comfortaa"/>
                         </a:rPr>
-                        <a:t>Auth / Usuarios</a:t>
+                        <a:t>Auth</a:t>
                       </a:r>
                     </a:p>
                   </a:txBody>
@@ -31562,7 +31562,7 @@
                           <a:ea typeface="Comfortaa"/>
                           <a:cs typeface="Comfortaa"/>
                         </a:rPr>
-                        <a:t>5101 / 5102</a:t>
+                        <a:t>5101</a:t>
                       </a:r>
                     </a:p>
                   </a:txBody>
@@ -31598,7 +31598,7 @@
                           <a:ea typeface="Comfortaa"/>
                           <a:cs typeface="Comfortaa"/>
                         </a:rPr>
-                        <a:t>Sesión común y perfiles</a:t>
+                        <a:t>Sesión común: login, renovación y revocación</a:t>
                       </a:r>
                     </a:p>
                   </a:txBody>
@@ -31621,7 +31621,7 @@
                   </a:tcPr>
                 </a:tc>
               </a:tr>
-              <a:tr h="554355">
+              <a:tr h="416052">
                 <a:tc>
                   <a:txBody>
                     <a:bodyPr/>
@@ -31636,7 +31636,7 @@
                           <a:ea typeface="Comfortaa"/>
                           <a:cs typeface="Comfortaa"/>
                         </a:rPr>
-                        <a:t>Productos</a:t>
+                        <a:t>Usuarios</a:t>
                       </a:r>
                     </a:p>
                   </a:txBody>
@@ -31678,7 +31678,7 @@
                           <a:ea typeface="Comfortaa"/>
                           <a:cs typeface="Comfortaa"/>
                         </a:rPr>
-                        <a:t>5103</a:t>
+                        <a:t>5102</a:t>
                       </a:r>
                     </a:p>
                   </a:txBody>
@@ -31714,7 +31714,7 @@
                           <a:ea typeface="Comfortaa"/>
                           <a:cs typeface="Comfortaa"/>
                         </a:rPr>
-                        <a:t>Catálogo comercial de solo lectura</a:t>
+                        <a:t>Perfil de la cuenta y directorio de usuarios</a:t>
                       </a:r>
                     </a:p>
                   </a:txBody>
@@ -31737,7 +31737,7 @@
                   </a:tcPr>
                 </a:tc>
               </a:tr>
-              <a:tr h="554355">
+              <a:tr h="416052">
                 <a:tc>
                   <a:txBody>
                     <a:bodyPr/>
@@ -31752,7 +31752,7 @@
                           <a:ea typeface="Comfortaa"/>
                           <a:cs typeface="Comfortaa"/>
                         </a:rPr>
-                        <a:t>Pedidos / Entregas</a:t>
+                        <a:t>Productos</a:t>
                       </a:r>
                     </a:p>
                   </a:txBody>
@@ -31794,7 +31794,7 @@
                           <a:ea typeface="Comfortaa"/>
                           <a:cs typeface="Comfortaa"/>
                         </a:rPr>
-                        <a:t>5104 / 5105</a:t>
+                        <a:t>5103</a:t>
                       </a:r>
                     </a:p>
                   </a:txBody>
@@ -31830,7 +31830,7 @@
                           <a:ea typeface="Comfortaa"/>
                           <a:cs typeface="Comfortaa"/>
                         </a:rPr>
-                        <a:t>Estados del pedido y cierre de entrega</a:t>
+                        <a:t>Catálogo comercial de solo lectura</a:t>
                       </a:r>
                     </a:p>
                   </a:txBody>
@@ -31853,7 +31853,239 @@
                   </a:tcPr>
                 </a:tc>
               </a:tr>
-              <a:tr h="554355">
+              <a:tr h="416052">
+                <a:tc>
+                  <a:txBody>
+                    <a:bodyPr/>
+                    <a:lstStyle/>
+                    <a:p>
+                      <a:r>
+                        <a:rPr sz="1600" b="0">
+                          <a:solidFill>
+                            <a:srgbClr val="514E58"/>
+                          </a:solidFill>
+                          <a:latin typeface="Comfortaa"/>
+                          <a:ea typeface="Comfortaa"/>
+                          <a:cs typeface="Comfortaa"/>
+                        </a:rPr>
+                        <a:t>Pedidos</a:t>
+                      </a:r>
+                    </a:p>
+                  </a:txBody>
+                  <a:tcPr marL="91440" marR="91440" marT="45720" marB="45720">
+                    <a:lnL w="5715">
+                      <a:solidFill>
+                        <a:srgbClr val="D5CCD9"/>
+                      </a:solidFill>
+                      <a:prstDash val="solid"/>
+                    </a:lnL>
+                    <a:lnR w="5715">
+                      <a:solidFill>
+                        <a:srgbClr val="D5CCD9"/>
+                      </a:solidFill>
+                      <a:prstDash val="solid"/>
+                    </a:lnR>
+                    <a:lnB w="5715">
+                      <a:solidFill>
+                        <a:srgbClr val="D5CCD9"/>
+                      </a:solidFill>
+                      <a:prstDash val="solid"/>
+                    </a:lnB>
+                    <a:solidFill>
+                      <a:srgbClr val="EAF0E5"/>
+                    </a:solidFill>
+                  </a:tcPr>
+                </a:tc>
+                <a:tc>
+                  <a:txBody>
+                    <a:bodyPr/>
+                    <a:lstStyle/>
+                    <a:p>
+                      <a:r>
+                        <a:rPr sz="1600" b="0">
+                          <a:solidFill>
+                            <a:srgbClr val="514E58"/>
+                          </a:solidFill>
+                          <a:latin typeface="Comfortaa"/>
+                          <a:ea typeface="Comfortaa"/>
+                          <a:cs typeface="Comfortaa"/>
+                        </a:rPr>
+                        <a:t>5104</a:t>
+                      </a:r>
+                    </a:p>
+                  </a:txBody>
+                  <a:tcPr marL="91440" marR="91440" marT="45720" marB="45720">
+                    <a:lnR w="5715">
+                      <a:solidFill>
+                        <a:srgbClr val="D5CCD9"/>
+                      </a:solidFill>
+                      <a:prstDash val="solid"/>
+                    </a:lnR>
+                    <a:lnB w="5715">
+                      <a:solidFill>
+                        <a:srgbClr val="D5CCD9"/>
+                      </a:solidFill>
+                      <a:prstDash val="solid"/>
+                    </a:lnB>
+                    <a:solidFill>
+                      <a:srgbClr val="EAF0E5"/>
+                    </a:solidFill>
+                  </a:tcPr>
+                </a:tc>
+                <a:tc>
+                  <a:txBody>
+                    <a:bodyPr/>
+                    <a:lstStyle/>
+                    <a:p>
+                      <a:r>
+                        <a:rPr sz="1600" b="0">
+                          <a:solidFill>
+                            <a:srgbClr val="514E58"/>
+                          </a:solidFill>
+                          <a:latin typeface="Comfortaa"/>
+                          <a:ea typeface="Comfortaa"/>
+                          <a:cs typeface="Comfortaa"/>
+                        </a:rPr>
+                        <a:t>Consulta, historial y estados del pedido</a:t>
+                      </a:r>
+                    </a:p>
+                  </a:txBody>
+                  <a:tcPr marL="91440" marR="91440" marT="45720" marB="45720">
+                    <a:lnR w="5715">
+                      <a:solidFill>
+                        <a:srgbClr val="D5CCD9"/>
+                      </a:solidFill>
+                      <a:prstDash val="solid"/>
+                    </a:lnR>
+                    <a:lnB w="5715">
+                      <a:solidFill>
+                        <a:srgbClr val="D5CCD9"/>
+                      </a:solidFill>
+                      <a:prstDash val="solid"/>
+                    </a:lnB>
+                    <a:solidFill>
+                      <a:srgbClr val="EAF0E5"/>
+                    </a:solidFill>
+                  </a:tcPr>
+                </a:tc>
+              </a:tr>
+              <a:tr h="416052">
+                <a:tc>
+                  <a:txBody>
+                    <a:bodyPr/>
+                    <a:lstStyle/>
+                    <a:p>
+                      <a:r>
+                        <a:rPr sz="1600" b="0">
+                          <a:solidFill>
+                            <a:srgbClr val="514E58"/>
+                          </a:solidFill>
+                          <a:latin typeface="Comfortaa"/>
+                          <a:ea typeface="Comfortaa"/>
+                          <a:cs typeface="Comfortaa"/>
+                        </a:rPr>
+                        <a:t>Entregas</a:t>
+                      </a:r>
+                    </a:p>
+                  </a:txBody>
+                  <a:tcPr marL="91440" marR="91440" marT="45720" marB="45720">
+                    <a:lnL w="5715">
+                      <a:solidFill>
+                        <a:srgbClr val="D5CCD9"/>
+                      </a:solidFill>
+                      <a:prstDash val="solid"/>
+                    </a:lnL>
+                    <a:lnR w="5715">
+                      <a:solidFill>
+                        <a:srgbClr val="D5CCD9"/>
+                      </a:solidFill>
+                      <a:prstDash val="solid"/>
+                    </a:lnR>
+                    <a:lnB w="5715">
+                      <a:solidFill>
+                        <a:srgbClr val="D5CCD9"/>
+                      </a:solidFill>
+                      <a:prstDash val="solid"/>
+                    </a:lnB>
+                    <a:solidFill>
+                      <a:srgbClr val="FAF8F4"/>
+                    </a:solidFill>
+                  </a:tcPr>
+                </a:tc>
+                <a:tc>
+                  <a:txBody>
+                    <a:bodyPr/>
+                    <a:lstStyle/>
+                    <a:p>
+                      <a:r>
+                        <a:rPr sz="1600" b="0">
+                          <a:solidFill>
+                            <a:srgbClr val="514E58"/>
+                          </a:solidFill>
+                          <a:latin typeface="Comfortaa"/>
+                          <a:ea typeface="Comfortaa"/>
+                          <a:cs typeface="Comfortaa"/>
+                        </a:rPr>
+                        <a:t>5105</a:t>
+                      </a:r>
+                    </a:p>
+                  </a:txBody>
+                  <a:tcPr marL="91440" marR="91440" marT="45720" marB="45720">
+                    <a:lnR w="5715">
+                      <a:solidFill>
+                        <a:srgbClr val="D5CCD9"/>
+                      </a:solidFill>
+                      <a:prstDash val="solid"/>
+                    </a:lnR>
+                    <a:lnB w="5715">
+                      <a:solidFill>
+                        <a:srgbClr val="D5CCD9"/>
+                      </a:solidFill>
+                      <a:prstDash val="solid"/>
+                    </a:lnB>
+                    <a:solidFill>
+                      <a:srgbClr val="FAF8F4"/>
+                    </a:solidFill>
+                  </a:tcPr>
+                </a:tc>
+                <a:tc>
+                  <a:txBody>
+                    <a:bodyPr/>
+                    <a:lstStyle/>
+                    <a:p>
+                      <a:r>
+                        <a:rPr sz="1600" b="0">
+                          <a:solidFill>
+                            <a:srgbClr val="514E58"/>
+                          </a:solidFill>
+                          <a:latin typeface="Comfortaa"/>
+                          <a:ea typeface="Comfortaa"/>
+                          <a:cs typeface="Comfortaa"/>
+                        </a:rPr>
+                        <a:t>Paradas del repartidor y cierre de la entrega</a:t>
+                      </a:r>
+                    </a:p>
+                  </a:txBody>
+                  <a:tcPr marL="91440" marR="91440" marT="45720" marB="45720">
+                    <a:lnR w="5715">
+                      <a:solidFill>
+                        <a:srgbClr val="D5CCD9"/>
+                      </a:solidFill>
+                      <a:prstDash val="solid"/>
+                    </a:lnR>
+                    <a:lnB w="5715">
+                      <a:solidFill>
+                        <a:srgbClr val="D5CCD9"/>
+                      </a:solidFill>
+                      <a:prstDash val="solid"/>
+                    </a:lnB>
+                    <a:solidFill>
+                      <a:srgbClr val="FAF8F4"/>
+                    </a:solidFill>
+                  </a:tcPr>
+                </a:tc>
+              </a:tr>
+              <a:tr h="416052">
                 <a:tc>
                   <a:txBody>
                     <a:bodyPr/>
@@ -31969,7 +32201,7 @@
                   </a:tcPr>
                 </a:tc>
               </a:tr>
-              <a:tr h="554355">
+              <a:tr h="416052">
                 <a:tc>
                   <a:txBody>
                     <a:bodyPr/>
@@ -31985,6 +32217,238 @@
                           <a:cs typeface="Comfortaa"/>
                         </a:rPr>
                         <a:t>Documentos</a:t>
+                      </a:r>
+                    </a:p>
+                  </a:txBody>
+                  <a:tcPr marL="91440" marR="91440" marT="45720" marB="45720">
+                    <a:lnL w="5715">
+                      <a:solidFill>
+                        <a:srgbClr val="D5CCD9"/>
+                      </a:solidFill>
+                      <a:prstDash val="solid"/>
+                    </a:lnL>
+                    <a:lnR w="5715">
+                      <a:solidFill>
+                        <a:srgbClr val="D5CCD9"/>
+                      </a:solidFill>
+                      <a:prstDash val="solid"/>
+                    </a:lnR>
+                    <a:lnB w="5715">
+                      <a:solidFill>
+                        <a:srgbClr val="D5CCD9"/>
+                      </a:solidFill>
+                      <a:prstDash val="solid"/>
+                    </a:lnB>
+                    <a:solidFill>
+                      <a:srgbClr val="EAF0E5"/>
+                    </a:solidFill>
+                  </a:tcPr>
+                </a:tc>
+                <a:tc>
+                  <a:txBody>
+                    <a:bodyPr/>
+                    <a:lstStyle/>
+                    <a:p>
+                      <a:r>
+                        <a:rPr sz="1600" b="0">
+                          <a:solidFill>
+                            <a:srgbClr val="514E58"/>
+                          </a:solidFill>
+                          <a:latin typeface="Comfortaa"/>
+                          <a:ea typeface="Comfortaa"/>
+                          <a:cs typeface="Comfortaa"/>
+                        </a:rPr>
+                        <a:t>5107</a:t>
+                      </a:r>
+                    </a:p>
+                  </a:txBody>
+                  <a:tcPr marL="91440" marR="91440" marT="45720" marB="45720">
+                    <a:lnR w="5715">
+                      <a:solidFill>
+                        <a:srgbClr val="D5CCD9"/>
+                      </a:solidFill>
+                      <a:prstDash val="solid"/>
+                    </a:lnR>
+                    <a:lnB w="5715">
+                      <a:solidFill>
+                        <a:srgbClr val="D5CCD9"/>
+                      </a:solidFill>
+                      <a:prstDash val="solid"/>
+                    </a:lnB>
+                    <a:solidFill>
+                      <a:srgbClr val="EAF0E5"/>
+                    </a:solidFill>
+                  </a:tcPr>
+                </a:tc>
+                <a:tc>
+                  <a:txBody>
+                    <a:bodyPr/>
+                    <a:lstStyle/>
+                    <a:p>
+                      <a:r>
+                        <a:rPr sz="1600" b="0">
+                          <a:solidFill>
+                            <a:srgbClr val="514E58"/>
+                          </a:solidFill>
+                          <a:latin typeface="Comfortaa"/>
+                          <a:ea typeface="Comfortaa"/>
+                          <a:cs typeface="Comfortaa"/>
+                        </a:rPr>
+                        <a:t>Archivos y evidencias en MongoDB</a:t>
+                      </a:r>
+                    </a:p>
+                  </a:txBody>
+                  <a:tcPr marL="91440" marR="91440" marT="45720" marB="45720">
+                    <a:lnR w="5715">
+                      <a:solidFill>
+                        <a:srgbClr val="D5CCD9"/>
+                      </a:solidFill>
+                      <a:prstDash val="solid"/>
+                    </a:lnR>
+                    <a:lnB w="5715">
+                      <a:solidFill>
+                        <a:srgbClr val="D5CCD9"/>
+                      </a:solidFill>
+                      <a:prstDash val="solid"/>
+                    </a:lnB>
+                    <a:solidFill>
+                      <a:srgbClr val="EAF0E5"/>
+                    </a:solidFill>
+                  </a:tcPr>
+                </a:tc>
+              </a:tr>
+              <a:tr h="416052">
+                <a:tc>
+                  <a:txBody>
+                    <a:bodyPr/>
+                    <a:lstStyle/>
+                    <a:p>
+                      <a:r>
+                        <a:rPr sz="1600" b="0">
+                          <a:solidFill>
+                            <a:srgbClr val="514E58"/>
+                          </a:solidFill>
+                          <a:latin typeface="Comfortaa"/>
+                          <a:ea typeface="Comfortaa"/>
+                          <a:cs typeface="Comfortaa"/>
+                        </a:rPr>
+                        <a:t>Zonas</a:t>
+                      </a:r>
+                    </a:p>
+                  </a:txBody>
+                  <a:tcPr marL="91440" marR="91440" marT="45720" marB="45720">
+                    <a:lnL w="5715">
+                      <a:solidFill>
+                        <a:srgbClr val="D5CCD9"/>
+                      </a:solidFill>
+                      <a:prstDash val="solid"/>
+                    </a:lnL>
+                    <a:lnR w="5715">
+                      <a:solidFill>
+                        <a:srgbClr val="D5CCD9"/>
+                      </a:solidFill>
+                      <a:prstDash val="solid"/>
+                    </a:lnR>
+                    <a:lnB w="5715">
+                      <a:solidFill>
+                        <a:srgbClr val="D5CCD9"/>
+                      </a:solidFill>
+                      <a:prstDash val="solid"/>
+                    </a:lnB>
+                    <a:solidFill>
+                      <a:srgbClr val="EAF0E5"/>
+                    </a:solidFill>
+                  </a:tcPr>
+                </a:tc>
+                <a:tc>
+                  <a:txBody>
+                    <a:bodyPr/>
+                    <a:lstStyle/>
+                    <a:p>
+                      <a:r>
+                        <a:rPr sz="1600" b="0">
+                          <a:solidFill>
+                            <a:srgbClr val="514E58"/>
+                          </a:solidFill>
+                          <a:latin typeface="Comfortaa"/>
+                          <a:ea typeface="Comfortaa"/>
+                          <a:cs typeface="Comfortaa"/>
+                        </a:rPr>
+                        <a:t>5108</a:t>
+                      </a:r>
+                    </a:p>
+                  </a:txBody>
+                  <a:tcPr marL="91440" marR="91440" marT="45720" marB="45720">
+                    <a:lnR w="5715">
+                      <a:solidFill>
+                        <a:srgbClr val="D5CCD9"/>
+                      </a:solidFill>
+                      <a:prstDash val="solid"/>
+                    </a:lnR>
+                    <a:lnB w="5715">
+                      <a:solidFill>
+                        <a:srgbClr val="D5CCD9"/>
+                      </a:solidFill>
+                      <a:prstDash val="solid"/>
+                    </a:lnB>
+                    <a:solidFill>
+                      <a:srgbClr val="EAF0E5"/>
+                    </a:solidFill>
+                  </a:tcPr>
+                </a:tc>
+                <a:tc>
+                  <a:txBody>
+                    <a:bodyPr/>
+                    <a:lstStyle/>
+                    <a:p>
+                      <a:r>
+                        <a:rPr sz="1600" b="0">
+                          <a:solidFill>
+                            <a:srgbClr val="514E58"/>
+                          </a:solidFill>
+                          <a:latin typeface="Comfortaa"/>
+                          <a:ea typeface="Comfortaa"/>
+                          <a:cs typeface="Comfortaa"/>
+                        </a:rPr>
+                        <a:t>Zonas de cobertura (colonias)</a:t>
+                      </a:r>
+                    </a:p>
+                  </a:txBody>
+                  <a:tcPr marL="91440" marR="91440" marT="45720" marB="45720">
+                    <a:lnR w="5715">
+                      <a:solidFill>
+                        <a:srgbClr val="D5CCD9"/>
+                      </a:solidFill>
+                      <a:prstDash val="solid"/>
+                    </a:lnR>
+                    <a:lnB w="5715">
+                      <a:solidFill>
+                        <a:srgbClr val="D5CCD9"/>
+                      </a:solidFill>
+                      <a:prstDash val="solid"/>
+                    </a:lnB>
+                    <a:solidFill>
+                      <a:srgbClr val="EAF0E5"/>
+                    </a:solidFill>
+                  </a:tcPr>
+                </a:tc>
+              </a:tr>
+              <a:tr h="416052">
+                <a:tc>
+                  <a:txBody>
+                    <a:bodyPr/>
+                    <a:lstStyle/>
+                    <a:p>
+                      <a:r>
+                        <a:rPr sz="1600" b="0">
+                          <a:solidFill>
+                            <a:srgbClr val="514E58"/>
+                          </a:solidFill>
+                          <a:latin typeface="Comfortaa"/>
+                          <a:ea typeface="Comfortaa"/>
+                          <a:cs typeface="Comfortaa"/>
+                        </a:rPr>
+                        <a:t>Microhubs</a:t>
                       </a:r>
                     </a:p>
                   </a:txBody>
@@ -32026,7 +32490,7 @@
                           <a:ea typeface="Comfortaa"/>
                           <a:cs typeface="Comfortaa"/>
                         </a:rPr>
-                        <a:t>5107</a:t>
+                        <a:t>5109</a:t>
                       </a:r>
                     </a:p>
                   </a:txBody>
@@ -32062,7 +32526,7 @@
                           <a:ea typeface="Comfortaa"/>
                           <a:cs typeface="Comfortaa"/>
                         </a:rPr>
-                        <a:t>Archivos y evidencias en MongoDB</a:t>
+                        <a:t>Red de microhubs y su radio de cobertura</a:t>
                       </a:r>
                     </a:p>
                   </a:txBody>
@@ -32085,123 +32549,7 @@
                   </a:tcPr>
                 </a:tc>
               </a:tr>
-              <a:tr h="554355">
-                <a:tc>
-                  <a:txBody>
-                    <a:bodyPr/>
-                    <a:lstStyle/>
-                    <a:p>
-                      <a:r>
-                        <a:rPr sz="1600" b="0">
-                          <a:solidFill>
-                            <a:srgbClr val="514E58"/>
-                          </a:solidFill>
-                          <a:latin typeface="Comfortaa"/>
-                          <a:ea typeface="Comfortaa"/>
-                          <a:cs typeface="Comfortaa"/>
-                        </a:rPr>
-                        <a:t>Zonas / Microhubs</a:t>
-                      </a:r>
-                    </a:p>
-                  </a:txBody>
-                  <a:tcPr marL="91440" marR="91440" marT="45720" marB="45720">
-                    <a:lnL w="5715">
-                      <a:solidFill>
-                        <a:srgbClr val="D5CCD9"/>
-                      </a:solidFill>
-                      <a:prstDash val="solid"/>
-                    </a:lnL>
-                    <a:lnR w="5715">
-                      <a:solidFill>
-                        <a:srgbClr val="D5CCD9"/>
-                      </a:solidFill>
-                      <a:prstDash val="solid"/>
-                    </a:lnR>
-                    <a:lnB w="5715">
-                      <a:solidFill>
-                        <a:srgbClr val="D5CCD9"/>
-                      </a:solidFill>
-                      <a:prstDash val="solid"/>
-                    </a:lnB>
-                    <a:solidFill>
-                      <a:srgbClr val="EAF0E5"/>
-                    </a:solidFill>
-                  </a:tcPr>
-                </a:tc>
-                <a:tc>
-                  <a:txBody>
-                    <a:bodyPr/>
-                    <a:lstStyle/>
-                    <a:p>
-                      <a:r>
-                        <a:rPr sz="1600" b="0">
-                          <a:solidFill>
-                            <a:srgbClr val="514E58"/>
-                          </a:solidFill>
-                          <a:latin typeface="Comfortaa"/>
-                          <a:ea typeface="Comfortaa"/>
-                          <a:cs typeface="Comfortaa"/>
-                        </a:rPr>
-                        <a:t>5108 / 5109</a:t>
-                      </a:r>
-                    </a:p>
-                  </a:txBody>
-                  <a:tcPr marL="91440" marR="91440" marT="45720" marB="45720">
-                    <a:lnR w="5715">
-                      <a:solidFill>
-                        <a:srgbClr val="D5CCD9"/>
-                      </a:solidFill>
-                      <a:prstDash val="solid"/>
-                    </a:lnR>
-                    <a:lnB w="5715">
-                      <a:solidFill>
-                        <a:srgbClr val="D5CCD9"/>
-                      </a:solidFill>
-                      <a:prstDash val="solid"/>
-                    </a:lnB>
-                    <a:solidFill>
-                      <a:srgbClr val="EAF0E5"/>
-                    </a:solidFill>
-                  </a:tcPr>
-                </a:tc>
-                <a:tc>
-                  <a:txBody>
-                    <a:bodyPr/>
-                    <a:lstStyle/>
-                    <a:p>
-                      <a:r>
-                        <a:rPr sz="1600" b="0">
-                          <a:solidFill>
-                            <a:srgbClr val="514E58"/>
-                          </a:solidFill>
-                          <a:latin typeface="Comfortaa"/>
-                          <a:ea typeface="Comfortaa"/>
-                          <a:cs typeface="Comfortaa"/>
-                        </a:rPr>
-                        <a:t>Cobertura y puntos de operación</a:t>
-                      </a:r>
-                    </a:p>
-                  </a:txBody>
-                  <a:tcPr marL="91440" marR="91440" marT="45720" marB="45720">
-                    <a:lnR w="5715">
-                      <a:solidFill>
-                        <a:srgbClr val="D5CCD9"/>
-                      </a:solidFill>
-                      <a:prstDash val="solid"/>
-                    </a:lnR>
-                    <a:lnB w="5715">
-                      <a:solidFill>
-                        <a:srgbClr val="D5CCD9"/>
-                      </a:solidFill>
-                      <a:prstDash val="solid"/>
-                    </a:lnB>
-                    <a:solidFill>
-                      <a:srgbClr val="EAF0E5"/>
-                    </a:solidFill>
-                  </a:tcPr>
-                </a:tc>
-              </a:tr>
-              <a:tr h="554355">
+              <a:tr h="416052">
                 <a:tc>
                   <a:txBody>
                     <a:bodyPr/>

</xml_diff>

<commit_message>
Ruth Soriano: textos finales, evidencia Git y deuda tecnica
- Reporte y documento de arquitectura: se reescriben los parrafos que hablaban de un ZIP
  y de una revision sin ejecutar; el reporte pasa a decir lo que se ejecuto el 13 de octubre.
- Evidencia Git con los PR #8 a #17 y los commits del video; deuda tecnica con la base
  compartida, la copia de codigo del web en planeacion y la lectura directa de MongoDB.
- Presentacion: diapositivas 27 y 31 y sus notas en lenguaje directo; guion en PDF regenerado.
- CAMBIOS_DOCUMENTACION_SEGUNDO_PARCIAL.md, LEEME de la presentacion y de capturas reescritos;
  se corrigen dos menciones de ocho microservicios.
</commit_message>
<xml_diff>
--- a/presentacion/Microhubs_Presentacion.pptx
+++ b/presentacion/Microhubs_Presentacion.pptx
@@ -1906,7 +1906,7 @@
           <a:lstStyle xmlns:a="http://schemas.openxmlformats.org/drawingml/2006/main"/>
           <a:p xmlns:a="http://schemas.openxmlformats.org/drawingml/2006/main">
             <a:r>
-              <a:t>Esta tabla representa la integración del código actual. El tablero consulta la salud de los diez servicios, los resúmenes y un ejemplo XML desde Zonas. La vista del pedido combina Pedidos, Entregas, Seguimiento y Documentos. Cada llamada utiliza el JWT del usuario y registra código HTTP, tiempo y traza. Si un servicio falla, el portal informa el problema y conserva el resto de su funcionamiento.</a:t>
+              <a:t>En esta tabla se ve qué servicios consulta cada pantalla del portal. El tablero revisa la salud de los diez servicios, los resúmenes y un ejemplo XML de Zonas. La vista del pedido junta Pedidos, Entregas, Seguimiento y Documentos. Cada llamada usa el JWT del usuario y deja el código HTTP, el tiempo y la traza. Si un servicio falla, el portal avisa y el resto sigue funcionando.</a:t>
             </a:r>
           </a:p>
         </p:txBody>
@@ -2256,7 +2256,7 @@
           <a:lstStyle xmlns:a="http://schemas.openxmlformats.org/drawingml/2006/main"/>
           <a:p xmlns:a="http://schemas.openxmlformats.org/drawingml/2006/main">
             <a:r>
-              <a:t>Para cerrar, la arquitectura actual separa los catálogos, mueve el GPS a Seguimiento y conserva los avisos mediante PostgreSQL y la web. El proyecto registra diez servicios y 93 casos aprobados. Quedan aspectos por comprobar o mejorar, como la caché y los validadores de MongoDB real. La siguiente etapa contempla TLS, secretos propios, nube y pruebas de carga.</a:t>
+              <a:t>Para cerrar: separamos los catálogos, movimos el GPS a Seguimiento y dejamos los avisos en PostgreSQL y en el portal. Tenemos diez servicios y 93 casos aprobados. Falta revisar la caché y los validadores de MongoDB en un entorno real. Lo siguiente es TLS, secretos propios, la nube y pruebas de carga.</a:t>
             </a:r>
           </a:p>
         </p:txBody>
@@ -2326,7 +2326,7 @@
           <a:lstStyle xmlns:a="http://schemas.openxmlformats.org/drawingml/2006/main"/>
           <a:p xmlns:a="http://schemas.openxmlformats.org/drawingml/2006/main">
             <a:r>
-              <a:t>Los cuatro apartados muestran las mejoras del proyecto. Ampliamos la planeación y los flujos de operación, conectamos diez servicios por HTTP y actualizamos la documentación. Las evidencias adjuntas registran 93 casos, que sirven para comprobar respuestas y cambios en los datos.</a:t>
+              <a:t>Los cuatro apartados muestran las mejoras del proyecto. Ampliamos la planeación y los flujos de operación, conectamos diez servicios por HTTP y actualizamos la documentación. Las evidencias registran 93 casos, que sirven para comprobar respuestas y cambios en los datos.</a:t>
             </a:r>
           </a:p>
         </p:txBody>
@@ -22486,7 +22486,7 @@
                 <a:ea typeface="Comfortaa"/>
                 <a:cs typeface="Comfortaa"/>
               </a:rPr>
-              <a:t>Integración del código actual: HTTP + JWT común, tiempo y X-Traza-Id por llamada.</a:t>
+              <a:t>Cada llamada lleva el JWT del usuario y registra el tiempo y el X-Traza-Id.</a:t>
             </a:r>
           </a:p>
         </p:txBody>
@@ -26933,7 +26933,7 @@
                 <a:ea typeface="Comfortaa"/>
                 <a:cs typeface="Comfortaa"/>
               </a:rPr>
-              <a:t>10 servicios y 93 casos aprobados en la ejecución adjunta.</a:t>
+              <a:t>10 servicios y 93 casos aprobados el 13 de octubre.</a:t>
             </a:r>
           </a:p>
         </p:txBody>

</xml_diff>